<commit_message>
docs: aplica identidade visual oficial setup.com.br (logo + paleta)
- Logo oficial (extraido da arte enviada) embutido na capa, rodape e
  fechamento do .docx e do .pptx; versao branca para fundos escuros.
- Paleta da marca extraida do logo: petroleo #003C54, azul #0E6E92,
  teal #1F97B4, aco #609CC0, cinza #A8A8A8 — aplicada a diagramas,
  faixas de titulo, tabelas e cards (substitui azul/ambar/verde genericos).
- Logo no topo do markdown-fonte.
</commit_message>
<xml_diff>
--- a/docs/Infraestrutura-IA-setup.com.br.pptx
+++ b/docs/Infraestrutura-IA-setup.com.br.pptx
@@ -3115,7 +3115,7 @@
             <a:avLst/>
           </a:prstGeom>
           <a:solidFill>
-            <a:srgbClr val="0F2740"/>
+            <a:srgbClr val="003C54"/>
           </a:solidFill>
           <a:ln>
             <a:noFill/>
@@ -3159,7 +3159,7 @@
             <a:avLst/>
           </a:prstGeom>
           <a:solidFill>
-            <a:srgbClr val="1F6FEB"/>
+            <a:srgbClr val="0E6E92"/>
           </a:solidFill>
           <a:ln>
             <a:noFill/>
@@ -3203,7 +3203,7 @@
             <a:avLst/>
           </a:prstGeom>
           <a:solidFill>
-            <a:srgbClr val="0FB5AE"/>
+            <a:srgbClr val="1F97B4"/>
           </a:solidFill>
           <a:ln>
             <a:noFill/>
@@ -3247,7 +3247,7 @@
             <a:avLst/>
           </a:prstGeom>
           <a:solidFill>
-            <a:srgbClr val="F5A623"/>
+            <a:srgbClr val="609CC0"/>
           </a:solidFill>
           <a:ln>
             <a:noFill/>
@@ -3276,16 +3276,40 @@
           </a:p>
         </p:txBody>
       </p:sp>
-      <p:sp>
-        <p:nvSpPr>
-          <p:cNvPr id="6" name="TextBox 5"/>
+      <p:pic>
+        <p:nvPicPr>
+          <p:cNvPr id="6" name="Picture 5" descr="setup_logo_white@hi.png"/>
+          <p:cNvPicPr>
+            <a:picLocks noChangeAspect="1"/>
+          </p:cNvPicPr>
+          <p:nvPr/>
+        </p:nvPicPr>
+        <p:blipFill>
+          <a:blip r:embed="rId2"/>
+          <a:stretch>
+            <a:fillRect/>
+          </a:stretch>
+        </p:blipFill>
+        <p:spPr>
+          <a:xfrm>
+            <a:off x="1005840" y="1554480"/>
+            <a:ext cx="1822269" cy="566928"/>
+          </a:xfrm>
+          <a:prstGeom prst="rect">
+            <a:avLst/>
+          </a:prstGeom>
+        </p:spPr>
+      </p:pic>
+      <p:sp>
+        <p:nvSpPr>
+          <p:cNvPr id="7" name="TextBox 6"/>
           <p:cNvSpPr txBox="1"/>
           <p:nvPr/>
         </p:nvSpPr>
         <p:spPr>
           <a:xfrm>
-            <a:off x="1005840" y="1828800"/>
-            <a:ext cx="10058400" cy="457200"/>
+            <a:off x="1005840" y="2468880"/>
+            <a:ext cx="10424160" cy="1463040"/>
           </a:xfrm>
           <a:prstGeom prst="rect">
             <a:avLst/>
@@ -3310,27 +3334,27 @@
               </a:spcAft>
             </a:pPr>
             <a:r>
-              <a:rPr sz="2200" b="1" i="0">
-                <a:solidFill>
-                  <a:srgbClr val="0FB5AE"/>
-                </a:solidFill>
-                <a:latin typeface="Calibri"/>
-              </a:rPr>
-              <a:t>setup.com.br</a:t>
-            </a:r>
-          </a:p>
-        </p:txBody>
-      </p:sp>
-      <p:sp>
-        <p:nvSpPr>
-          <p:cNvPr id="7" name="TextBox 6"/>
+              <a:rPr sz="4800" b="1" i="0">
+                <a:solidFill>
+                  <a:srgbClr val="FFFFFF"/>
+                </a:solidFill>
+                <a:latin typeface="Calibri"/>
+              </a:rPr>
+              <a:t>Infraestrutura de TI com IA</a:t>
+            </a:r>
+          </a:p>
+        </p:txBody>
+      </p:sp>
+      <p:sp>
+        <p:nvSpPr>
+          <p:cNvPr id="8" name="TextBox 7"/>
           <p:cNvSpPr txBox="1"/>
           <p:nvPr/>
         </p:nvSpPr>
         <p:spPr>
           <a:xfrm>
-            <a:off x="1005840" y="2468880"/>
-            <a:ext cx="10424160" cy="1463040"/>
+            <a:off x="1024128" y="3931920"/>
+            <a:ext cx="10058400" cy="548640"/>
           </a:xfrm>
           <a:prstGeom prst="rect">
             <a:avLst/>
@@ -3355,26 +3379,26 @@
               </a:spcAft>
             </a:pPr>
             <a:r>
-              <a:rPr sz="4800" b="1" i="0">
-                <a:solidFill>
-                  <a:srgbClr val="FFFFFF"/>
-                </a:solidFill>
-                <a:latin typeface="Calibri"/>
-              </a:rPr>
-              <a:t>Infraestrutura de TI com IA</a:t>
-            </a:r>
-          </a:p>
-        </p:txBody>
-      </p:sp>
-      <p:sp>
-        <p:nvSpPr>
-          <p:cNvPr id="8" name="TextBox 7"/>
+              <a:rPr sz="1800" b="0" i="0">
+                <a:solidFill>
+                  <a:srgbClr val="609CC0"/>
+                </a:solidFill>
+                <a:latin typeface="Calibri"/>
+              </a:rPr>
+              <a:t>Produtividade aumentada por agentes, multimodelo e harness loop</a:t>
+            </a:r>
+          </a:p>
+        </p:txBody>
+      </p:sp>
+      <p:sp>
+        <p:nvSpPr>
+          <p:cNvPr id="9" name="TextBox 8"/>
           <p:cNvSpPr txBox="1"/>
           <p:nvPr/>
         </p:nvSpPr>
         <p:spPr>
           <a:xfrm>
-            <a:off x="1024128" y="3931920"/>
+            <a:off x="1024128" y="4572000"/>
             <a:ext cx="10058400" cy="548640"/>
           </a:xfrm>
           <a:prstGeom prst="rect">
@@ -3400,27 +3424,27 @@
               </a:spcAft>
             </a:pPr>
             <a:r>
-              <a:rPr sz="1800" b="0" i="0">
-                <a:solidFill>
-                  <a:srgbClr val="AFC6E0"/>
-                </a:solidFill>
-                <a:latin typeface="Calibri"/>
-              </a:rPr>
-              <a:t>Produtividade aumentada por agentes, multimodelo e harness loop</a:t>
-            </a:r>
-          </a:p>
-        </p:txBody>
-      </p:sp>
-      <p:sp>
-        <p:nvSpPr>
-          <p:cNvPr id="9" name="TextBox 8"/>
+              <a:rPr sz="1300" b="0" i="1">
+                <a:solidFill>
+                  <a:srgbClr val="609CC0"/>
+                </a:solidFill>
+                <a:latin typeface="Calibri"/>
+              </a:rPr>
+              <a:t>Integração: PC · Notebook · Tablet · Smartphone · WhatsApp · Google Workspace</a:t>
+            </a:r>
+          </a:p>
+        </p:txBody>
+      </p:sp>
+      <p:sp>
+        <p:nvSpPr>
+          <p:cNvPr id="10" name="TextBox 9"/>
           <p:cNvSpPr txBox="1"/>
           <p:nvPr/>
         </p:nvSpPr>
         <p:spPr>
           <a:xfrm>
-            <a:off x="1024128" y="4572000"/>
-            <a:ext cx="10058400" cy="548640"/>
+            <a:off x="1005840" y="5943600"/>
+            <a:ext cx="10058400" cy="365760"/>
           </a:xfrm>
           <a:prstGeom prst="rect">
             <a:avLst/>
@@ -3445,54 +3469,9 @@
               </a:spcAft>
             </a:pPr>
             <a:r>
-              <a:rPr sz="1300" b="0" i="1">
-                <a:solidFill>
-                  <a:srgbClr val="8FA8C4"/>
-                </a:solidFill>
-                <a:latin typeface="Calibri"/>
-              </a:rPr>
-              <a:t>Integração: PC · Notebook · Tablet · Smartphone · WhatsApp · Google Workspace</a:t>
-            </a:r>
-          </a:p>
-        </p:txBody>
-      </p:sp>
-      <p:sp>
-        <p:nvSpPr>
-          <p:cNvPr id="10" name="TextBox 9"/>
-          <p:cNvSpPr txBox="1"/>
-          <p:nvPr/>
-        </p:nvSpPr>
-        <p:spPr>
-          <a:xfrm>
-            <a:off x="1005840" y="5943600"/>
-            <a:ext cx="10058400" cy="365760"/>
-          </a:xfrm>
-          <a:prstGeom prst="rect">
-            <a:avLst/>
-          </a:prstGeom>
-          <a:noFill/>
-        </p:spPr>
-        <p:txBody>
-          <a:bodyPr wrap="square" anchor="t" lIns="0" rIns="0" tIns="0" bIns="0">
-            <a:spAutoFit/>
-          </a:bodyPr>
-          <a:lstStyle/>
-          <a:p>
-            <a:pPr algn="l">
-              <a:lnSpc>
-                <a:spcPct val="105000"/>
-              </a:lnSpc>
-              <a:spcBef>
-                <a:spcPts val="0"/>
-              </a:spcBef>
-              <a:spcAft>
-                <a:spcPts val="600"/>
-              </a:spcAft>
-            </a:pPr>
-            <a:r>
               <a:rPr sz="1100" b="1" i="0">
                 <a:solidFill>
-                  <a:srgbClr val="6E84A0"/>
+                  <a:srgbClr val="609CC0"/>
                 </a:solidFill>
                 <a:latin typeface="Calibri"/>
               </a:rPr>
@@ -3534,7 +3513,7 @@
             <a:avLst/>
           </a:prstGeom>
           <a:solidFill>
-            <a:srgbClr val="0F2740"/>
+            <a:srgbClr val="003C54"/>
           </a:solidFill>
           <a:ln>
             <a:noFill/>
@@ -3578,7 +3557,7 @@
             <a:avLst/>
           </a:prstGeom>
           <a:solidFill>
-            <a:srgbClr val="0F2740"/>
+            <a:srgbClr val="003C54"/>
           </a:solidFill>
           <a:ln>
             <a:noFill/>
@@ -3643,7 +3622,7 @@
             <a:r>
               <a:rPr sz="1200" b="1" i="0">
                 <a:solidFill>
-                  <a:srgbClr val="0FB5AE"/>
+                  <a:srgbClr val="1F97B4"/>
                 </a:solidFill>
                 <a:latin typeface="Calibri"/>
               </a:rPr>
@@ -3730,7 +3709,7 @@
             <a:r>
               <a:rPr sz="1550" b="1">
                 <a:solidFill>
-                  <a:srgbClr val="0F2740"/>
+                  <a:srgbClr val="003C54"/>
                 </a:solidFill>
                 <a:latin typeface="Calibri"/>
               </a:rPr>
@@ -3739,7 +3718,7 @@
             <a:r>
               <a:rPr sz="1550" b="1">
                 <a:solidFill>
-                  <a:srgbClr val="0F2740"/>
+                  <a:srgbClr val="003C54"/>
                 </a:solidFill>
                 <a:latin typeface="Calibri"/>
               </a:rPr>
@@ -3767,7 +3746,7 @@
             <a:r>
               <a:rPr sz="1550" b="1">
                 <a:solidFill>
-                  <a:srgbClr val="0F2740"/>
+                  <a:srgbClr val="003C54"/>
                 </a:solidFill>
                 <a:latin typeface="Calibri"/>
               </a:rPr>
@@ -3776,7 +3755,7 @@
             <a:r>
               <a:rPr sz="1550" b="1">
                 <a:solidFill>
-                  <a:srgbClr val="0F2740"/>
+                  <a:srgbClr val="003C54"/>
                 </a:solidFill>
                 <a:latin typeface="Calibri"/>
               </a:rPr>
@@ -3804,7 +3783,7 @@
             <a:r>
               <a:rPr sz="1550" b="1">
                 <a:solidFill>
-                  <a:srgbClr val="0F2740"/>
+                  <a:srgbClr val="003C54"/>
                 </a:solidFill>
                 <a:latin typeface="Calibri"/>
               </a:rPr>
@@ -3813,7 +3792,7 @@
             <a:r>
               <a:rPr sz="1550" b="1">
                 <a:solidFill>
-                  <a:srgbClr val="0F2740"/>
+                  <a:srgbClr val="003C54"/>
                 </a:solidFill>
                 <a:latin typeface="Calibri"/>
               </a:rPr>
@@ -3841,7 +3820,7 @@
             <a:r>
               <a:rPr sz="1550" b="1">
                 <a:solidFill>
-                  <a:srgbClr val="0F2740"/>
+                  <a:srgbClr val="003C54"/>
                 </a:solidFill>
                 <a:latin typeface="Calibri"/>
               </a:rPr>
@@ -3850,7 +3829,7 @@
             <a:r>
               <a:rPr sz="1550" b="1">
                 <a:solidFill>
-                  <a:srgbClr val="0F2740"/>
+                  <a:srgbClr val="003C54"/>
                 </a:solidFill>
                 <a:latin typeface="Calibri"/>
               </a:rPr>
@@ -3878,7 +3857,7 @@
             <a:r>
               <a:rPr sz="1550" b="1">
                 <a:solidFill>
-                  <a:srgbClr val="0F2740"/>
+                  <a:srgbClr val="003C54"/>
                 </a:solidFill>
                 <a:latin typeface="Calibri"/>
               </a:rPr>
@@ -3887,7 +3866,7 @@
             <a:r>
               <a:rPr sz="1550" b="1">
                 <a:solidFill>
-                  <a:srgbClr val="0F2740"/>
+                  <a:srgbClr val="003C54"/>
                 </a:solidFill>
                 <a:latin typeface="Calibri"/>
               </a:rPr>
@@ -3915,7 +3894,7 @@
             <a:r>
               <a:rPr sz="1550" b="1">
                 <a:solidFill>
-                  <a:srgbClr val="0F2740"/>
+                  <a:srgbClr val="003C54"/>
                 </a:solidFill>
                 <a:latin typeface="Calibri"/>
               </a:rPr>
@@ -3924,7 +3903,7 @@
             <a:r>
               <a:rPr sz="1550" b="1">
                 <a:solidFill>
-                  <a:srgbClr val="0F2740"/>
+                  <a:srgbClr val="003C54"/>
                 </a:solidFill>
                 <a:latin typeface="Calibri"/>
               </a:rPr>
@@ -3942,15 +3921,39 @@
           </a:p>
         </p:txBody>
       </p:sp>
-      <p:sp>
-        <p:nvSpPr>
-          <p:cNvPr id="7" name="TextBox 6"/>
+      <p:pic>
+        <p:nvPicPr>
+          <p:cNvPr id="7" name="Picture 6" descr="setup_logo@hi.png"/>
+          <p:cNvPicPr>
+            <a:picLocks noChangeAspect="1"/>
+          </p:cNvPicPr>
+          <p:nvPr/>
+        </p:nvPicPr>
+        <p:blipFill>
+          <a:blip r:embed="rId2"/>
+          <a:stretch>
+            <a:fillRect/>
+          </a:stretch>
+        </p:blipFill>
+        <p:spPr>
+          <a:xfrm>
+            <a:off x="502920" y="6419088"/>
+            <a:ext cx="646611" cy="201168"/>
+          </a:xfrm>
+          <a:prstGeom prst="rect">
+            <a:avLst/>
+          </a:prstGeom>
+        </p:spPr>
+      </p:pic>
+      <p:sp>
+        <p:nvSpPr>
+          <p:cNvPr id="8" name="TextBox 7"/>
           <p:cNvSpPr txBox="1"/>
           <p:nvPr/>
         </p:nvSpPr>
         <p:spPr>
           <a:xfrm>
-            <a:off x="502920" y="6455664"/>
+            <a:off x="1554480" y="6455664"/>
             <a:ext cx="8229600" cy="274320"/>
           </a:xfrm>
           <a:prstGeom prst="rect">
@@ -3978,18 +3981,18 @@
             <a:r>
               <a:rPr sz="900" b="0" i="0">
                 <a:solidFill>
-                  <a:srgbClr val="5B6B7B"/>
-                </a:solidFill>
-                <a:latin typeface="Calibri"/>
-              </a:rPr>
-              <a:t>setup.com.br  ·  Infraestrutura de TI com IA  ·  Documento Executivo</a:t>
-            </a:r>
-          </a:p>
-        </p:txBody>
-      </p:sp>
-      <p:sp>
-        <p:nvSpPr>
-          <p:cNvPr id="8" name="TextBox 7"/>
+                  <a:srgbClr val="5E6A72"/>
+                </a:solidFill>
+                <a:latin typeface="Calibri"/>
+              </a:rPr>
+              <a:t>Infraestrutura de TI com IA  ·  Documento Executivo</a:t>
+            </a:r>
+          </a:p>
+        </p:txBody>
+      </p:sp>
+      <p:sp>
+        <p:nvSpPr>
+          <p:cNvPr id="9" name="TextBox 8"/>
           <p:cNvSpPr txBox="1"/>
           <p:nvPr/>
         </p:nvSpPr>
@@ -4023,7 +4026,7 @@
             <a:r>
               <a:rPr sz="900" b="1" i="0">
                 <a:solidFill>
-                  <a:srgbClr val="5B6B7B"/>
+                  <a:srgbClr val="5E6A72"/>
                 </a:solidFill>
                 <a:latin typeface="Calibri"/>
               </a:rPr>
@@ -4065,7 +4068,7 @@
             <a:avLst/>
           </a:prstGeom>
           <a:solidFill>
-            <a:srgbClr val="F5A623"/>
+            <a:srgbClr val="4E86AE"/>
           </a:solidFill>
           <a:ln>
             <a:noFill/>
@@ -4130,7 +4133,7 @@
             <a:r>
               <a:rPr sz="1300" b="1" i="0">
                 <a:solidFill>
-                  <a:srgbClr val="0F2740"/>
+                  <a:srgbClr val="003C54"/>
                 </a:solidFill>
                 <a:latin typeface="Calibri"/>
               </a:rPr>
@@ -4163,15 +4166,39 @@
           </a:prstGeom>
         </p:spPr>
       </p:pic>
-      <p:sp>
-        <p:nvSpPr>
-          <p:cNvPr id="5" name="TextBox 4"/>
+      <p:pic>
+        <p:nvPicPr>
+          <p:cNvPr id="5" name="Picture 4" descr="setup_logo@hi.png"/>
+          <p:cNvPicPr>
+            <a:picLocks noChangeAspect="1"/>
+          </p:cNvPicPr>
+          <p:nvPr/>
+        </p:nvPicPr>
+        <p:blipFill>
+          <a:blip r:embed="rId3"/>
+          <a:stretch>
+            <a:fillRect/>
+          </a:stretch>
+        </p:blipFill>
+        <p:spPr>
+          <a:xfrm>
+            <a:off x="502920" y="6419088"/>
+            <a:ext cx="646611" cy="201168"/>
+          </a:xfrm>
+          <a:prstGeom prst="rect">
+            <a:avLst/>
+          </a:prstGeom>
+        </p:spPr>
+      </p:pic>
+      <p:sp>
+        <p:nvSpPr>
+          <p:cNvPr id="6" name="TextBox 5"/>
           <p:cNvSpPr txBox="1"/>
           <p:nvPr/>
         </p:nvSpPr>
         <p:spPr>
           <a:xfrm>
-            <a:off x="502920" y="6455664"/>
+            <a:off x="1554480" y="6455664"/>
             <a:ext cx="8229600" cy="274320"/>
           </a:xfrm>
           <a:prstGeom prst="rect">
@@ -4199,18 +4226,18 @@
             <a:r>
               <a:rPr sz="900" b="0" i="0">
                 <a:solidFill>
-                  <a:srgbClr val="5B6B7B"/>
-                </a:solidFill>
-                <a:latin typeface="Calibri"/>
-              </a:rPr>
-              <a:t>setup.com.br  ·  Infraestrutura de TI com IA  ·  Documento Executivo</a:t>
-            </a:r>
-          </a:p>
-        </p:txBody>
-      </p:sp>
-      <p:sp>
-        <p:nvSpPr>
-          <p:cNvPr id="6" name="TextBox 5"/>
+                  <a:srgbClr val="5E6A72"/>
+                </a:solidFill>
+                <a:latin typeface="Calibri"/>
+              </a:rPr>
+              <a:t>Infraestrutura de TI com IA  ·  Documento Executivo</a:t>
+            </a:r>
+          </a:p>
+        </p:txBody>
+      </p:sp>
+      <p:sp>
+        <p:nvSpPr>
+          <p:cNvPr id="7" name="TextBox 6"/>
           <p:cNvSpPr txBox="1"/>
           <p:nvPr/>
         </p:nvSpPr>
@@ -4244,7 +4271,7 @@
             <a:r>
               <a:rPr sz="900" b="1" i="0">
                 <a:solidFill>
-                  <a:srgbClr val="5B6B7B"/>
+                  <a:srgbClr val="5E6A72"/>
                 </a:solidFill>
                 <a:latin typeface="Calibri"/>
               </a:rPr>
@@ -4286,7 +4313,7 @@
             <a:avLst/>
           </a:prstGeom>
           <a:solidFill>
-            <a:srgbClr val="0F2740"/>
+            <a:srgbClr val="003C54"/>
           </a:solidFill>
           <a:ln>
             <a:noFill/>
@@ -4351,7 +4378,7 @@
             <a:r>
               <a:rPr sz="1300" b="1" i="0">
                 <a:solidFill>
-                  <a:srgbClr val="0F2740"/>
+                  <a:srgbClr val="003C54"/>
                 </a:solidFill>
                 <a:latin typeface="Calibri"/>
               </a:rPr>
@@ -4420,7 +4447,7 @@
             <a:r>
               <a:rPr sz="1350" b="0" i="1">
                 <a:solidFill>
-                  <a:srgbClr val="5B6B7B"/>
+                  <a:srgbClr val="5E6A72"/>
                 </a:solidFill>
                 <a:latin typeface="Calibri"/>
               </a:rPr>
@@ -4429,15 +4456,39 @@
           </a:p>
         </p:txBody>
       </p:sp>
-      <p:sp>
-        <p:nvSpPr>
-          <p:cNvPr id="6" name="TextBox 5"/>
+      <p:pic>
+        <p:nvPicPr>
+          <p:cNvPr id="6" name="Picture 5" descr="setup_logo@hi.png"/>
+          <p:cNvPicPr>
+            <a:picLocks noChangeAspect="1"/>
+          </p:cNvPicPr>
+          <p:nvPr/>
+        </p:nvPicPr>
+        <p:blipFill>
+          <a:blip r:embed="rId3"/>
+          <a:stretch>
+            <a:fillRect/>
+          </a:stretch>
+        </p:blipFill>
+        <p:spPr>
+          <a:xfrm>
+            <a:off x="502920" y="6419088"/>
+            <a:ext cx="646611" cy="201168"/>
+          </a:xfrm>
+          <a:prstGeom prst="rect">
+            <a:avLst/>
+          </a:prstGeom>
+        </p:spPr>
+      </p:pic>
+      <p:sp>
+        <p:nvSpPr>
+          <p:cNvPr id="7" name="TextBox 6"/>
           <p:cNvSpPr txBox="1"/>
           <p:nvPr/>
         </p:nvSpPr>
         <p:spPr>
           <a:xfrm>
-            <a:off x="502920" y="6455664"/>
+            <a:off x="1554480" y="6455664"/>
             <a:ext cx="8229600" cy="274320"/>
           </a:xfrm>
           <a:prstGeom prst="rect">
@@ -4465,18 +4516,18 @@
             <a:r>
               <a:rPr sz="900" b="0" i="0">
                 <a:solidFill>
-                  <a:srgbClr val="5B6B7B"/>
-                </a:solidFill>
-                <a:latin typeface="Calibri"/>
-              </a:rPr>
-              <a:t>setup.com.br  ·  Infraestrutura de TI com IA  ·  Documento Executivo</a:t>
-            </a:r>
-          </a:p>
-        </p:txBody>
-      </p:sp>
-      <p:sp>
-        <p:nvSpPr>
-          <p:cNvPr id="7" name="TextBox 6"/>
+                  <a:srgbClr val="5E6A72"/>
+                </a:solidFill>
+                <a:latin typeface="Calibri"/>
+              </a:rPr>
+              <a:t>Infraestrutura de TI com IA  ·  Documento Executivo</a:t>
+            </a:r>
+          </a:p>
+        </p:txBody>
+      </p:sp>
+      <p:sp>
+        <p:nvSpPr>
+          <p:cNvPr id="8" name="TextBox 7"/>
           <p:cNvSpPr txBox="1"/>
           <p:nvPr/>
         </p:nvSpPr>
@@ -4510,7 +4561,7 @@
             <a:r>
               <a:rPr sz="900" b="1" i="0">
                 <a:solidFill>
-                  <a:srgbClr val="5B6B7B"/>
+                  <a:srgbClr val="5E6A72"/>
                 </a:solidFill>
                 <a:latin typeface="Calibri"/>
               </a:rPr>
@@ -4552,7 +4603,7 @@
             <a:avLst/>
           </a:prstGeom>
           <a:solidFill>
-            <a:srgbClr val="0F2740"/>
+            <a:srgbClr val="003C54"/>
           </a:solidFill>
           <a:ln>
             <a:noFill/>
@@ -4596,7 +4647,7 @@
             <a:avLst/>
           </a:prstGeom>
           <a:solidFill>
-            <a:srgbClr val="1F6FEB"/>
+            <a:srgbClr val="0E6E92"/>
           </a:solidFill>
           <a:ln>
             <a:noFill/>
@@ -4640,7 +4691,7 @@
             <a:avLst/>
           </a:prstGeom>
           <a:solidFill>
-            <a:srgbClr val="0FB5AE"/>
+            <a:srgbClr val="1F97B4"/>
           </a:solidFill>
           <a:ln>
             <a:noFill/>
@@ -4684,7 +4735,7 @@
             <a:avLst/>
           </a:prstGeom>
           <a:solidFill>
-            <a:srgbClr val="F5A623"/>
+            <a:srgbClr val="609CC0"/>
           </a:solidFill>
           <a:ln>
             <a:noFill/>
@@ -4749,7 +4800,7 @@
             <a:r>
               <a:rPr sz="1600" b="1" i="0">
                 <a:solidFill>
-                  <a:srgbClr val="0FB5AE"/>
+                  <a:srgbClr val="1F97B4"/>
                 </a:solidFill>
                 <a:latin typeface="Calibri"/>
               </a:rPr>
@@ -4803,51 +4854,30 @@
           </a:p>
         </p:txBody>
       </p:sp>
-      <p:sp>
-        <p:nvSpPr>
-          <p:cNvPr id="8" name="TextBox 7"/>
-          <p:cNvSpPr txBox="1"/>
-          <p:nvPr/>
-        </p:nvSpPr>
-        <p:spPr>
-          <a:xfrm>
-            <a:off x="1097280" y="5852160"/>
-            <a:ext cx="10058400" cy="457200"/>
-          </a:xfrm>
-          <a:prstGeom prst="rect">
-            <a:avLst/>
-          </a:prstGeom>
-          <a:noFill/>
-        </p:spPr>
-        <p:txBody>
-          <a:bodyPr wrap="square" anchor="t" lIns="0" rIns="0" tIns="0" bIns="0">
-            <a:spAutoFit/>
-          </a:bodyPr>
-          <a:lstStyle/>
-          <a:p>
-            <a:pPr algn="l">
-              <a:lnSpc>
-                <a:spcPct val="105000"/>
-              </a:lnSpc>
-              <a:spcBef>
-                <a:spcPts val="0"/>
-              </a:spcBef>
-              <a:spcAft>
-                <a:spcPts val="600"/>
-              </a:spcAft>
-            </a:pPr>
-            <a:r>
-              <a:rPr sz="1300" b="0" i="0">
-                <a:solidFill>
-                  <a:srgbClr val="8FA8C4"/>
-                </a:solidFill>
-                <a:latin typeface="Calibri"/>
-              </a:rPr>
-              <a:t>setup.com.br  ·  Infraestrutura de TI com IA</a:t>
-            </a:r>
-          </a:p>
-        </p:txBody>
-      </p:sp>
+      <p:pic>
+        <p:nvPicPr>
+          <p:cNvPr id="8" name="Picture 7" descr="setup_logo_white@hi.png"/>
+          <p:cNvPicPr>
+            <a:picLocks noChangeAspect="1"/>
+          </p:cNvPicPr>
+          <p:nvPr/>
+        </p:nvPicPr>
+        <p:blipFill>
+          <a:blip r:embed="rId2"/>
+          <a:stretch>
+            <a:fillRect/>
+          </a:stretch>
+        </p:blipFill>
+        <p:spPr>
+          <a:xfrm>
+            <a:off x="1097280" y="5760720"/>
+            <a:ext cx="1469571" cy="457200"/>
+          </a:xfrm>
+          <a:prstGeom prst="rect">
+            <a:avLst/>
+          </a:prstGeom>
+        </p:spPr>
+      </p:pic>
     </p:spTree>
   </p:cSld>
   <p:clrMapOvr>
@@ -4881,7 +4911,7 @@
             <a:avLst/>
           </a:prstGeom>
           <a:solidFill>
-            <a:srgbClr val="0F2740"/>
+            <a:srgbClr val="003C54"/>
           </a:solidFill>
           <a:ln>
             <a:noFill/>
@@ -4925,7 +4955,7 @@
             <a:avLst/>
           </a:prstGeom>
           <a:solidFill>
-            <a:srgbClr val="1F6FEB"/>
+            <a:srgbClr val="0E6E92"/>
           </a:solidFill>
           <a:ln>
             <a:noFill/>
@@ -4990,7 +5020,7 @@
             <a:r>
               <a:rPr sz="1200" b="1" i="0">
                 <a:solidFill>
-                  <a:srgbClr val="0FB5AE"/>
+                  <a:srgbClr val="1F97B4"/>
                 </a:solidFill>
                 <a:latin typeface="Calibri"/>
               </a:rPr>
@@ -5106,7 +5136,7 @@
             </a:avLst>
           </a:prstGeom>
           <a:solidFill>
-            <a:srgbClr val="F2F5F8"/>
+            <a:srgbClr val="F1F4F6"/>
           </a:solidFill>
           <a:ln>
             <a:noFill/>
@@ -5150,7 +5180,7 @@
             <a:avLst/>
           </a:prstGeom>
           <a:solidFill>
-            <a:srgbClr val="1F6FEB"/>
+            <a:srgbClr val="0E6E92"/>
           </a:solidFill>
           <a:ln>
             <a:noFill/>
@@ -5215,7 +5245,7 @@
             <a:r>
               <a:rPr sz="1600" b="1" i="0">
                 <a:solidFill>
-                  <a:srgbClr val="1F6FEB"/>
+                  <a:srgbClr val="0E6E92"/>
                 </a:solidFill>
                 <a:latin typeface="Calibri"/>
               </a:rPr>
@@ -5287,7 +5317,7 @@
             </a:avLst>
           </a:prstGeom>
           <a:solidFill>
-            <a:srgbClr val="F2F5F8"/>
+            <a:srgbClr val="F1F4F6"/>
           </a:solidFill>
           <a:ln>
             <a:noFill/>
@@ -5331,7 +5361,7 @@
             <a:avLst/>
           </a:prstGeom>
           <a:solidFill>
-            <a:srgbClr val="0FB5AE"/>
+            <a:srgbClr val="1F97B4"/>
           </a:solidFill>
           <a:ln>
             <a:noFill/>
@@ -5396,7 +5426,7 @@
             <a:r>
               <a:rPr sz="1600" b="1" i="0">
                 <a:solidFill>
-                  <a:srgbClr val="0FB5AE"/>
+                  <a:srgbClr val="1F97B4"/>
                 </a:solidFill>
                 <a:latin typeface="Calibri"/>
               </a:rPr>
@@ -5468,7 +5498,7 @@
             </a:avLst>
           </a:prstGeom>
           <a:solidFill>
-            <a:srgbClr val="F2F5F8"/>
+            <a:srgbClr val="F1F4F6"/>
           </a:solidFill>
           <a:ln>
             <a:noFill/>
@@ -5512,7 +5542,7 @@
             <a:avLst/>
           </a:prstGeom>
           <a:solidFill>
-            <a:srgbClr val="F5A623"/>
+            <a:srgbClr val="4E86AE"/>
           </a:solidFill>
           <a:ln>
             <a:noFill/>
@@ -5577,7 +5607,7 @@
             <a:r>
               <a:rPr sz="1600" b="1" i="0">
                 <a:solidFill>
-                  <a:srgbClr val="F5A623"/>
+                  <a:srgbClr val="4E86AE"/>
                 </a:solidFill>
                 <a:latin typeface="Calibri"/>
               </a:rPr>
@@ -5649,7 +5679,7 @@
             </a:avLst>
           </a:prstGeom>
           <a:solidFill>
-            <a:srgbClr val="E6F7F6"/>
+            <a:srgbClr val="E1F0F4"/>
           </a:solidFill>
           <a:ln>
             <a:noFill/>
@@ -5714,7 +5744,7 @@
             <a:r>
               <a:rPr sz="1400" b="1" i="0">
                 <a:solidFill>
-                  <a:srgbClr val="0F2740"/>
+                  <a:srgbClr val="003C54"/>
                 </a:solidFill>
                 <a:latin typeface="Calibri"/>
               </a:rPr>
@@ -5732,15 +5762,39 @@
           </a:p>
         </p:txBody>
       </p:sp>
-      <p:sp>
-        <p:nvSpPr>
-          <p:cNvPr id="21" name="TextBox 20"/>
+      <p:pic>
+        <p:nvPicPr>
+          <p:cNvPr id="21" name="Picture 20" descr="setup_logo@hi.png"/>
+          <p:cNvPicPr>
+            <a:picLocks noChangeAspect="1"/>
+          </p:cNvPicPr>
+          <p:nvPr/>
+        </p:nvPicPr>
+        <p:blipFill>
+          <a:blip r:embed="rId2"/>
+          <a:stretch>
+            <a:fillRect/>
+          </a:stretch>
+        </p:blipFill>
+        <p:spPr>
+          <a:xfrm>
+            <a:off x="502920" y="6419088"/>
+            <a:ext cx="646611" cy="201168"/>
+          </a:xfrm>
+          <a:prstGeom prst="rect">
+            <a:avLst/>
+          </a:prstGeom>
+        </p:spPr>
+      </p:pic>
+      <p:sp>
+        <p:nvSpPr>
+          <p:cNvPr id="22" name="TextBox 21"/>
           <p:cNvSpPr txBox="1"/>
           <p:nvPr/>
         </p:nvSpPr>
         <p:spPr>
           <a:xfrm>
-            <a:off x="502920" y="6455664"/>
+            <a:off x="1554480" y="6455664"/>
             <a:ext cx="8229600" cy="274320"/>
           </a:xfrm>
           <a:prstGeom prst="rect">
@@ -5768,18 +5822,18 @@
             <a:r>
               <a:rPr sz="900" b="0" i="0">
                 <a:solidFill>
-                  <a:srgbClr val="5B6B7B"/>
-                </a:solidFill>
-                <a:latin typeface="Calibri"/>
-              </a:rPr>
-              <a:t>setup.com.br  ·  Infraestrutura de TI com IA  ·  Documento Executivo</a:t>
-            </a:r>
-          </a:p>
-        </p:txBody>
-      </p:sp>
-      <p:sp>
-        <p:nvSpPr>
-          <p:cNvPr id="22" name="TextBox 21"/>
+                  <a:srgbClr val="5E6A72"/>
+                </a:solidFill>
+                <a:latin typeface="Calibri"/>
+              </a:rPr>
+              <a:t>Infraestrutura de TI com IA  ·  Documento Executivo</a:t>
+            </a:r>
+          </a:p>
+        </p:txBody>
+      </p:sp>
+      <p:sp>
+        <p:nvSpPr>
+          <p:cNvPr id="23" name="TextBox 22"/>
           <p:cNvSpPr txBox="1"/>
           <p:nvPr/>
         </p:nvSpPr>
@@ -5813,7 +5867,7 @@
             <a:r>
               <a:rPr sz="900" b="1" i="0">
                 <a:solidFill>
-                  <a:srgbClr val="5B6B7B"/>
+                  <a:srgbClr val="5E6A72"/>
                 </a:solidFill>
                 <a:latin typeface="Calibri"/>
               </a:rPr>
@@ -5855,7 +5909,7 @@
             <a:avLst/>
           </a:prstGeom>
           <a:solidFill>
-            <a:srgbClr val="1F6FEB"/>
+            <a:srgbClr val="0E6E92"/>
           </a:solidFill>
           <a:ln>
             <a:noFill/>
@@ -5920,7 +5974,7 @@
             <a:r>
               <a:rPr sz="1300" b="1" i="0">
                 <a:solidFill>
-                  <a:srgbClr val="0F2740"/>
+                  <a:srgbClr val="003C54"/>
                 </a:solidFill>
                 <a:latin typeface="Calibri"/>
               </a:rPr>
@@ -5953,15 +6007,39 @@
           </a:prstGeom>
         </p:spPr>
       </p:pic>
-      <p:sp>
-        <p:nvSpPr>
-          <p:cNvPr id="5" name="TextBox 4"/>
+      <p:pic>
+        <p:nvPicPr>
+          <p:cNvPr id="5" name="Picture 4" descr="setup_logo@hi.png"/>
+          <p:cNvPicPr>
+            <a:picLocks noChangeAspect="1"/>
+          </p:cNvPicPr>
+          <p:nvPr/>
+        </p:nvPicPr>
+        <p:blipFill>
+          <a:blip r:embed="rId3"/>
+          <a:stretch>
+            <a:fillRect/>
+          </a:stretch>
+        </p:blipFill>
+        <p:spPr>
+          <a:xfrm>
+            <a:off x="502920" y="6419088"/>
+            <a:ext cx="646611" cy="201168"/>
+          </a:xfrm>
+          <a:prstGeom prst="rect">
+            <a:avLst/>
+          </a:prstGeom>
+        </p:spPr>
+      </p:pic>
+      <p:sp>
+        <p:nvSpPr>
+          <p:cNvPr id="6" name="TextBox 5"/>
           <p:cNvSpPr txBox="1"/>
           <p:nvPr/>
         </p:nvSpPr>
         <p:spPr>
           <a:xfrm>
-            <a:off x="502920" y="6455664"/>
+            <a:off x="1554480" y="6455664"/>
             <a:ext cx="8229600" cy="274320"/>
           </a:xfrm>
           <a:prstGeom prst="rect">
@@ -5989,18 +6067,18 @@
             <a:r>
               <a:rPr sz="900" b="0" i="0">
                 <a:solidFill>
-                  <a:srgbClr val="5B6B7B"/>
-                </a:solidFill>
-                <a:latin typeface="Calibri"/>
-              </a:rPr>
-              <a:t>setup.com.br  ·  Infraestrutura de TI com IA  ·  Documento Executivo</a:t>
-            </a:r>
-          </a:p>
-        </p:txBody>
-      </p:sp>
-      <p:sp>
-        <p:nvSpPr>
-          <p:cNvPr id="6" name="TextBox 5"/>
+                  <a:srgbClr val="5E6A72"/>
+                </a:solidFill>
+                <a:latin typeface="Calibri"/>
+              </a:rPr>
+              <a:t>Infraestrutura de TI com IA  ·  Documento Executivo</a:t>
+            </a:r>
+          </a:p>
+        </p:txBody>
+      </p:sp>
+      <p:sp>
+        <p:nvSpPr>
+          <p:cNvPr id="7" name="TextBox 6"/>
           <p:cNvSpPr txBox="1"/>
           <p:nvPr/>
         </p:nvSpPr>
@@ -6034,7 +6112,7 @@
             <a:r>
               <a:rPr sz="900" b="1" i="0">
                 <a:solidFill>
-                  <a:srgbClr val="5B6B7B"/>
+                  <a:srgbClr val="5E6A72"/>
                 </a:solidFill>
                 <a:latin typeface="Calibri"/>
               </a:rPr>
@@ -6076,7 +6154,7 @@
             <a:avLst/>
           </a:prstGeom>
           <a:solidFill>
-            <a:srgbClr val="0F2740"/>
+            <a:srgbClr val="003C54"/>
           </a:solidFill>
           <a:ln>
             <a:noFill/>
@@ -6120,7 +6198,7 @@
             <a:avLst/>
           </a:prstGeom>
           <a:solidFill>
-            <a:srgbClr val="1F6FEB"/>
+            <a:srgbClr val="0E6E92"/>
           </a:solidFill>
           <a:ln>
             <a:noFill/>
@@ -6185,7 +6263,7 @@
             <a:r>
               <a:rPr sz="1200" b="1" i="0">
                 <a:solidFill>
-                  <a:srgbClr val="0FB5AE"/>
+                  <a:srgbClr val="1F97B4"/>
                 </a:solidFill>
                 <a:latin typeface="Calibri"/>
               </a:rPr>
@@ -6301,7 +6379,7 @@
             </a:avLst>
           </a:prstGeom>
           <a:solidFill>
-            <a:srgbClr val="1F6FEB"/>
+            <a:srgbClr val="0E6E92"/>
           </a:solidFill>
           <a:ln>
             <a:noFill/>
@@ -6437,7 +6515,7 @@
             </a:avLst>
           </a:prstGeom>
           <a:solidFill>
-            <a:srgbClr val="0FB5AE"/>
+            <a:srgbClr val="1F97B4"/>
           </a:solidFill>
           <a:ln>
             <a:noFill/>
@@ -6573,7 +6651,7 @@
             </a:avLst>
           </a:prstGeom>
           <a:solidFill>
-            <a:srgbClr val="F5A623"/>
+            <a:srgbClr val="4E86AE"/>
           </a:solidFill>
           <a:ln>
             <a:noFill/>
@@ -6709,7 +6787,7 @@
             </a:avLst>
           </a:prstGeom>
           <a:solidFill>
-            <a:srgbClr val="2E8B57"/>
+            <a:srgbClr val="003C54"/>
           </a:solidFill>
           <a:ln>
             <a:noFill/>
@@ -6845,7 +6923,7 @@
             </a:avLst>
           </a:prstGeom>
           <a:solidFill>
-            <a:srgbClr val="5B6B7B"/>
+            <a:srgbClr val="5E6A72"/>
           </a:solidFill>
           <a:ln>
             <a:noFill/>
@@ -6964,15 +7042,39 @@
           </a:p>
         </p:txBody>
       </p:sp>
-      <p:sp>
-        <p:nvSpPr>
-          <p:cNvPr id="22" name="TextBox 21"/>
+      <p:pic>
+        <p:nvPicPr>
+          <p:cNvPr id="22" name="Picture 21" descr="setup_logo@hi.png"/>
+          <p:cNvPicPr>
+            <a:picLocks noChangeAspect="1"/>
+          </p:cNvPicPr>
+          <p:nvPr/>
+        </p:nvPicPr>
+        <p:blipFill>
+          <a:blip r:embed="rId2"/>
+          <a:stretch>
+            <a:fillRect/>
+          </a:stretch>
+        </p:blipFill>
+        <p:spPr>
+          <a:xfrm>
+            <a:off x="502920" y="6419088"/>
+            <a:ext cx="646611" cy="201168"/>
+          </a:xfrm>
+          <a:prstGeom prst="rect">
+            <a:avLst/>
+          </a:prstGeom>
+        </p:spPr>
+      </p:pic>
+      <p:sp>
+        <p:nvSpPr>
+          <p:cNvPr id="23" name="TextBox 22"/>
           <p:cNvSpPr txBox="1"/>
           <p:nvPr/>
         </p:nvSpPr>
         <p:spPr>
           <a:xfrm>
-            <a:off x="502920" y="6455664"/>
+            <a:off x="1554480" y="6455664"/>
             <a:ext cx="8229600" cy="274320"/>
           </a:xfrm>
           <a:prstGeom prst="rect">
@@ -7000,18 +7102,18 @@
             <a:r>
               <a:rPr sz="900" b="0" i="0">
                 <a:solidFill>
-                  <a:srgbClr val="5B6B7B"/>
-                </a:solidFill>
-                <a:latin typeface="Calibri"/>
-              </a:rPr>
-              <a:t>setup.com.br  ·  Infraestrutura de TI com IA  ·  Documento Executivo</a:t>
-            </a:r>
-          </a:p>
-        </p:txBody>
-      </p:sp>
-      <p:sp>
-        <p:nvSpPr>
-          <p:cNvPr id="23" name="TextBox 22"/>
+                  <a:srgbClr val="5E6A72"/>
+                </a:solidFill>
+                <a:latin typeface="Calibri"/>
+              </a:rPr>
+              <a:t>Infraestrutura de TI com IA  ·  Documento Executivo</a:t>
+            </a:r>
+          </a:p>
+        </p:txBody>
+      </p:sp>
+      <p:sp>
+        <p:nvSpPr>
+          <p:cNvPr id="24" name="TextBox 23"/>
           <p:cNvSpPr txBox="1"/>
           <p:nvPr/>
         </p:nvSpPr>
@@ -7045,7 +7147,7 @@
             <a:r>
               <a:rPr sz="900" b="1" i="0">
                 <a:solidFill>
-                  <a:srgbClr val="5B6B7B"/>
+                  <a:srgbClr val="5E6A72"/>
                 </a:solidFill>
                 <a:latin typeface="Calibri"/>
               </a:rPr>
@@ -7087,7 +7189,7 @@
             <a:avLst/>
           </a:prstGeom>
           <a:solidFill>
-            <a:srgbClr val="1F6FEB"/>
+            <a:srgbClr val="0E6E92"/>
           </a:solidFill>
           <a:ln>
             <a:noFill/>
@@ -7152,7 +7254,7 @@
             <a:r>
               <a:rPr sz="1300" b="1" i="0">
                 <a:solidFill>
-                  <a:srgbClr val="0F2740"/>
+                  <a:srgbClr val="003C54"/>
                 </a:solidFill>
                 <a:latin typeface="Calibri"/>
               </a:rPr>
@@ -7221,7 +7323,7 @@
             <a:r>
               <a:rPr sz="1350" b="0" i="1">
                 <a:solidFill>
-                  <a:srgbClr val="5B6B7B"/>
+                  <a:srgbClr val="5E6A72"/>
                 </a:solidFill>
                 <a:latin typeface="Calibri"/>
               </a:rPr>
@@ -7230,15 +7332,39 @@
           </a:p>
         </p:txBody>
       </p:sp>
-      <p:sp>
-        <p:nvSpPr>
-          <p:cNvPr id="6" name="TextBox 5"/>
+      <p:pic>
+        <p:nvPicPr>
+          <p:cNvPr id="6" name="Picture 5" descr="setup_logo@hi.png"/>
+          <p:cNvPicPr>
+            <a:picLocks noChangeAspect="1"/>
+          </p:cNvPicPr>
+          <p:nvPr/>
+        </p:nvPicPr>
+        <p:blipFill>
+          <a:blip r:embed="rId3"/>
+          <a:stretch>
+            <a:fillRect/>
+          </a:stretch>
+        </p:blipFill>
+        <p:spPr>
+          <a:xfrm>
+            <a:off x="502920" y="6419088"/>
+            <a:ext cx="646611" cy="201168"/>
+          </a:xfrm>
+          <a:prstGeom prst="rect">
+            <a:avLst/>
+          </a:prstGeom>
+        </p:spPr>
+      </p:pic>
+      <p:sp>
+        <p:nvSpPr>
+          <p:cNvPr id="7" name="TextBox 6"/>
           <p:cNvSpPr txBox="1"/>
           <p:nvPr/>
         </p:nvSpPr>
         <p:spPr>
           <a:xfrm>
-            <a:off x="502920" y="6455664"/>
+            <a:off x="1554480" y="6455664"/>
             <a:ext cx="8229600" cy="274320"/>
           </a:xfrm>
           <a:prstGeom prst="rect">
@@ -7266,18 +7392,18 @@
             <a:r>
               <a:rPr sz="900" b="0" i="0">
                 <a:solidFill>
-                  <a:srgbClr val="5B6B7B"/>
-                </a:solidFill>
-                <a:latin typeface="Calibri"/>
-              </a:rPr>
-              <a:t>setup.com.br  ·  Infraestrutura de TI com IA  ·  Documento Executivo</a:t>
-            </a:r>
-          </a:p>
-        </p:txBody>
-      </p:sp>
-      <p:sp>
-        <p:nvSpPr>
-          <p:cNvPr id="7" name="TextBox 6"/>
+                  <a:srgbClr val="5E6A72"/>
+                </a:solidFill>
+                <a:latin typeface="Calibri"/>
+              </a:rPr>
+              <a:t>Infraestrutura de TI com IA  ·  Documento Executivo</a:t>
+            </a:r>
+          </a:p>
+        </p:txBody>
+      </p:sp>
+      <p:sp>
+        <p:nvSpPr>
+          <p:cNvPr id="8" name="TextBox 7"/>
           <p:cNvSpPr txBox="1"/>
           <p:nvPr/>
         </p:nvSpPr>
@@ -7311,7 +7437,7 @@
             <a:r>
               <a:rPr sz="900" b="1" i="0">
                 <a:solidFill>
-                  <a:srgbClr val="5B6B7B"/>
+                  <a:srgbClr val="5E6A72"/>
                 </a:solidFill>
                 <a:latin typeface="Calibri"/>
               </a:rPr>
@@ -7353,7 +7479,7 @@
             <a:avLst/>
           </a:prstGeom>
           <a:solidFill>
-            <a:srgbClr val="0FB5AE"/>
+            <a:srgbClr val="1F97B4"/>
           </a:solidFill>
           <a:ln>
             <a:noFill/>
@@ -7418,7 +7544,7 @@
             <a:r>
               <a:rPr sz="1300" b="1" i="0">
                 <a:solidFill>
-                  <a:srgbClr val="0F2740"/>
+                  <a:srgbClr val="003C54"/>
                 </a:solidFill>
                 <a:latin typeface="Calibri"/>
               </a:rPr>
@@ -7487,7 +7613,7 @@
             <a:r>
               <a:rPr sz="1600" b="1" i="0">
                 <a:solidFill>
-                  <a:srgbClr val="0F2740"/>
+                  <a:srgbClr val="003C54"/>
                 </a:solidFill>
                 <a:latin typeface="Calibri"/>
               </a:rPr>
@@ -7529,7 +7655,7 @@
             <a:r>
               <a:rPr sz="1400" b="1">
                 <a:solidFill>
-                  <a:srgbClr val="0FB5AE"/>
+                  <a:srgbClr val="1F97B4"/>
                 </a:solidFill>
                 <a:latin typeface="Calibri"/>
               </a:rPr>
@@ -7538,7 +7664,7 @@
             <a:r>
               <a:rPr sz="1400" b="1">
                 <a:solidFill>
-                  <a:srgbClr val="0F2740"/>
+                  <a:srgbClr val="003C54"/>
                 </a:solidFill>
                 <a:latin typeface="Calibri"/>
               </a:rPr>
@@ -7566,7 +7692,7 @@
             <a:r>
               <a:rPr sz="1400" b="1">
                 <a:solidFill>
-                  <a:srgbClr val="0FB5AE"/>
+                  <a:srgbClr val="1F97B4"/>
                 </a:solidFill>
                 <a:latin typeface="Calibri"/>
               </a:rPr>
@@ -7575,7 +7701,7 @@
             <a:r>
               <a:rPr sz="1400" b="1">
                 <a:solidFill>
-                  <a:srgbClr val="0F2740"/>
+                  <a:srgbClr val="003C54"/>
                 </a:solidFill>
                 <a:latin typeface="Calibri"/>
               </a:rPr>
@@ -7603,7 +7729,7 @@
             <a:r>
               <a:rPr sz="1400" b="1">
                 <a:solidFill>
-                  <a:srgbClr val="0FB5AE"/>
+                  <a:srgbClr val="1F97B4"/>
                 </a:solidFill>
                 <a:latin typeface="Calibri"/>
               </a:rPr>
@@ -7612,7 +7738,7 @@
             <a:r>
               <a:rPr sz="1400" b="1">
                 <a:solidFill>
-                  <a:srgbClr val="0F2740"/>
+                  <a:srgbClr val="003C54"/>
                 </a:solidFill>
                 <a:latin typeface="Calibri"/>
               </a:rPr>
@@ -7647,7 +7773,7 @@
             </a:avLst>
           </a:prstGeom>
           <a:solidFill>
-            <a:srgbClr val="FDF3E0"/>
+            <a:srgbClr val="E8F1F8"/>
           </a:solidFill>
           <a:ln>
             <a:noFill/>
@@ -7712,7 +7838,7 @@
             <a:r>
               <a:rPr sz="1300" b="1" i="0">
                 <a:solidFill>
-                  <a:srgbClr val="0F2740"/>
+                  <a:srgbClr val="003C54"/>
                 </a:solidFill>
                 <a:latin typeface="Calibri"/>
               </a:rPr>
@@ -7730,15 +7856,39 @@
           </a:p>
         </p:txBody>
       </p:sp>
-      <p:sp>
-        <p:nvSpPr>
-          <p:cNvPr id="9" name="TextBox 8"/>
+      <p:pic>
+        <p:nvPicPr>
+          <p:cNvPr id="9" name="Picture 8" descr="setup_logo@hi.png"/>
+          <p:cNvPicPr>
+            <a:picLocks noChangeAspect="1"/>
+          </p:cNvPicPr>
+          <p:nvPr/>
+        </p:nvPicPr>
+        <p:blipFill>
+          <a:blip r:embed="rId3"/>
+          <a:stretch>
+            <a:fillRect/>
+          </a:stretch>
+        </p:blipFill>
+        <p:spPr>
+          <a:xfrm>
+            <a:off x="502920" y="6419088"/>
+            <a:ext cx="646611" cy="201168"/>
+          </a:xfrm>
+          <a:prstGeom prst="rect">
+            <a:avLst/>
+          </a:prstGeom>
+        </p:spPr>
+      </p:pic>
+      <p:sp>
+        <p:nvSpPr>
+          <p:cNvPr id="10" name="TextBox 9"/>
           <p:cNvSpPr txBox="1"/>
           <p:nvPr/>
         </p:nvSpPr>
         <p:spPr>
           <a:xfrm>
-            <a:off x="502920" y="6455664"/>
+            <a:off x="1554480" y="6455664"/>
             <a:ext cx="8229600" cy="274320"/>
           </a:xfrm>
           <a:prstGeom prst="rect">
@@ -7766,18 +7916,18 @@
             <a:r>
               <a:rPr sz="900" b="0" i="0">
                 <a:solidFill>
-                  <a:srgbClr val="5B6B7B"/>
-                </a:solidFill>
-                <a:latin typeface="Calibri"/>
-              </a:rPr>
-              <a:t>setup.com.br  ·  Infraestrutura de TI com IA  ·  Documento Executivo</a:t>
-            </a:r>
-          </a:p>
-        </p:txBody>
-      </p:sp>
-      <p:sp>
-        <p:nvSpPr>
-          <p:cNvPr id="10" name="TextBox 9"/>
+                  <a:srgbClr val="5E6A72"/>
+                </a:solidFill>
+                <a:latin typeface="Calibri"/>
+              </a:rPr>
+              <a:t>Infraestrutura de TI com IA  ·  Documento Executivo</a:t>
+            </a:r>
+          </a:p>
+        </p:txBody>
+      </p:sp>
+      <p:sp>
+        <p:nvSpPr>
+          <p:cNvPr id="11" name="TextBox 10"/>
           <p:cNvSpPr txBox="1"/>
           <p:nvPr/>
         </p:nvSpPr>
@@ -7811,7 +7961,7 @@
             <a:r>
               <a:rPr sz="900" b="1" i="0">
                 <a:solidFill>
-                  <a:srgbClr val="5B6B7B"/>
+                  <a:srgbClr val="5E6A72"/>
                 </a:solidFill>
                 <a:latin typeface="Calibri"/>
               </a:rPr>
@@ -7853,7 +8003,7 @@
             <a:avLst/>
           </a:prstGeom>
           <a:solidFill>
-            <a:srgbClr val="0F2740"/>
+            <a:srgbClr val="003C54"/>
           </a:solidFill>
           <a:ln>
             <a:noFill/>
@@ -7897,7 +8047,7 @@
             <a:avLst/>
           </a:prstGeom>
           <a:solidFill>
-            <a:srgbClr val="1F6FEB"/>
+            <a:srgbClr val="0E6E92"/>
           </a:solidFill>
           <a:ln>
             <a:noFill/>
@@ -7962,7 +8112,7 @@
             <a:r>
               <a:rPr sz="1200" b="1" i="0">
                 <a:solidFill>
-                  <a:srgbClr val="0FB5AE"/>
+                  <a:srgbClr val="1F97B4"/>
                 </a:solidFill>
                 <a:latin typeface="Calibri"/>
               </a:rPr>
@@ -8078,7 +8228,7 @@
             </a:avLst>
           </a:prstGeom>
           <a:solidFill>
-            <a:srgbClr val="F2F5F8"/>
+            <a:srgbClr val="F1F4F6"/>
           </a:solidFill>
           <a:ln>
             <a:noFill/>
@@ -8122,7 +8272,7 @@
             <a:avLst/>
           </a:prstGeom>
           <a:solidFill>
-            <a:srgbClr val="1F6FEB"/>
+            <a:srgbClr val="0E6E92"/>
           </a:solidFill>
           <a:ln>
             <a:noFill/>
@@ -8187,7 +8337,7 @@
             <a:r>
               <a:rPr sz="1450" b="1" i="0">
                 <a:solidFill>
-                  <a:srgbClr val="1F6FEB"/>
+                  <a:srgbClr val="0E6E92"/>
                 </a:solidFill>
                 <a:latin typeface="Calibri"/>
               </a:rPr>
@@ -8258,7 +8408,7 @@
             </a:avLst>
           </a:prstGeom>
           <a:solidFill>
-            <a:srgbClr val="F2F5F8"/>
+            <a:srgbClr val="F1F4F6"/>
           </a:solidFill>
           <a:ln>
             <a:noFill/>
@@ -8302,7 +8452,7 @@
             <a:avLst/>
           </a:prstGeom>
           <a:solidFill>
-            <a:srgbClr val="0FB5AE"/>
+            <a:srgbClr val="1F97B4"/>
           </a:solidFill>
           <a:ln>
             <a:noFill/>
@@ -8367,7 +8517,7 @@
             <a:r>
               <a:rPr sz="1450" b="1" i="0">
                 <a:solidFill>
-                  <a:srgbClr val="0FB5AE"/>
+                  <a:srgbClr val="1F97B4"/>
                 </a:solidFill>
                 <a:latin typeface="Calibri"/>
               </a:rPr>
@@ -8438,7 +8588,7 @@
             </a:avLst>
           </a:prstGeom>
           <a:solidFill>
-            <a:srgbClr val="F2F5F8"/>
+            <a:srgbClr val="F1F4F6"/>
           </a:solidFill>
           <a:ln>
             <a:noFill/>
@@ -8482,7 +8632,7 @@
             <a:avLst/>
           </a:prstGeom>
           <a:solidFill>
-            <a:srgbClr val="F5A623"/>
+            <a:srgbClr val="4E86AE"/>
           </a:solidFill>
           <a:ln>
             <a:noFill/>
@@ -8547,7 +8697,7 @@
             <a:r>
               <a:rPr sz="1450" b="1" i="0">
                 <a:solidFill>
-                  <a:srgbClr val="F5A623"/>
+                  <a:srgbClr val="4E86AE"/>
                 </a:solidFill>
                 <a:latin typeface="Calibri"/>
               </a:rPr>
@@ -8618,7 +8768,7 @@
             </a:avLst>
           </a:prstGeom>
           <a:solidFill>
-            <a:srgbClr val="F2F5F8"/>
+            <a:srgbClr val="F1F4F6"/>
           </a:solidFill>
           <a:ln>
             <a:noFill/>
@@ -8662,7 +8812,7 @@
             <a:avLst/>
           </a:prstGeom>
           <a:solidFill>
-            <a:srgbClr val="2E8B57"/>
+            <a:srgbClr val="003C54"/>
           </a:solidFill>
           <a:ln>
             <a:noFill/>
@@ -8727,7 +8877,7 @@
             <a:r>
               <a:rPr sz="1450" b="1" i="0">
                 <a:solidFill>
-                  <a:srgbClr val="2E8B57"/>
+                  <a:srgbClr val="003C54"/>
                 </a:solidFill>
                 <a:latin typeface="Calibri"/>
               </a:rPr>
@@ -8798,7 +8948,7 @@
             </a:avLst>
           </a:prstGeom>
           <a:solidFill>
-            <a:srgbClr val="F2F5F8"/>
+            <a:srgbClr val="F1F4F6"/>
           </a:solidFill>
           <a:ln>
             <a:noFill/>
@@ -8842,7 +8992,7 @@
             <a:avLst/>
           </a:prstGeom>
           <a:solidFill>
-            <a:srgbClr val="5B6B7B"/>
+            <a:srgbClr val="5E6A72"/>
           </a:solidFill>
           <a:ln>
             <a:noFill/>
@@ -8907,7 +9057,7 @@
             <a:r>
               <a:rPr sz="1450" b="1" i="0">
                 <a:solidFill>
-                  <a:srgbClr val="5B6B7B"/>
+                  <a:srgbClr val="5E6A72"/>
                 </a:solidFill>
                 <a:latin typeface="Calibri"/>
               </a:rPr>
@@ -8978,7 +9128,7 @@
             </a:avLst>
           </a:prstGeom>
           <a:solidFill>
-            <a:srgbClr val="F2F5F8"/>
+            <a:srgbClr val="F1F4F6"/>
           </a:solidFill>
           <a:ln>
             <a:noFill/>
@@ -9022,7 +9172,7 @@
             <a:avLst/>
           </a:prstGeom>
           <a:solidFill>
-            <a:srgbClr val="1F6FEB"/>
+            <a:srgbClr val="0E6E92"/>
           </a:solidFill>
           <a:ln>
             <a:noFill/>
@@ -9087,7 +9237,7 @@
             <a:r>
               <a:rPr sz="1450" b="1" i="0">
                 <a:solidFill>
-                  <a:srgbClr val="1F6FEB"/>
+                  <a:srgbClr val="0E6E92"/>
                 </a:solidFill>
                 <a:latin typeface="Calibri"/>
               </a:rPr>
@@ -9158,7 +9308,7 @@
             </a:avLst>
           </a:prstGeom>
           <a:solidFill>
-            <a:srgbClr val="F2F5F8"/>
+            <a:srgbClr val="F1F4F6"/>
           </a:solidFill>
           <a:ln>
             <a:noFill/>
@@ -9202,7 +9352,7 @@
             <a:avLst/>
           </a:prstGeom>
           <a:solidFill>
-            <a:srgbClr val="0FB5AE"/>
+            <a:srgbClr val="1F97B4"/>
           </a:solidFill>
           <a:ln>
             <a:noFill/>
@@ -9267,7 +9417,7 @@
             <a:r>
               <a:rPr sz="1450" b="1" i="0">
                 <a:solidFill>
-                  <a:srgbClr val="0FB5AE"/>
+                  <a:srgbClr val="1F97B4"/>
                 </a:solidFill>
                 <a:latin typeface="Calibri"/>
               </a:rPr>
@@ -9321,15 +9471,39 @@
           </a:p>
         </p:txBody>
       </p:sp>
-      <p:sp>
-        <p:nvSpPr>
-          <p:cNvPr id="35" name="TextBox 34"/>
+      <p:pic>
+        <p:nvPicPr>
+          <p:cNvPr id="35" name="Picture 34" descr="setup_logo@hi.png"/>
+          <p:cNvPicPr>
+            <a:picLocks noChangeAspect="1"/>
+          </p:cNvPicPr>
+          <p:nvPr/>
+        </p:nvPicPr>
+        <p:blipFill>
+          <a:blip r:embed="rId2"/>
+          <a:stretch>
+            <a:fillRect/>
+          </a:stretch>
+        </p:blipFill>
+        <p:spPr>
+          <a:xfrm>
+            <a:off x="502920" y="6419088"/>
+            <a:ext cx="646611" cy="201168"/>
+          </a:xfrm>
+          <a:prstGeom prst="rect">
+            <a:avLst/>
+          </a:prstGeom>
+        </p:spPr>
+      </p:pic>
+      <p:sp>
+        <p:nvSpPr>
+          <p:cNvPr id="36" name="TextBox 35"/>
           <p:cNvSpPr txBox="1"/>
           <p:nvPr/>
         </p:nvSpPr>
         <p:spPr>
           <a:xfrm>
-            <a:off x="502920" y="6455664"/>
+            <a:off x="1554480" y="6455664"/>
             <a:ext cx="8229600" cy="274320"/>
           </a:xfrm>
           <a:prstGeom prst="rect">
@@ -9357,18 +9531,18 @@
             <a:r>
               <a:rPr sz="900" b="0" i="0">
                 <a:solidFill>
-                  <a:srgbClr val="5B6B7B"/>
-                </a:solidFill>
-                <a:latin typeface="Calibri"/>
-              </a:rPr>
-              <a:t>setup.com.br  ·  Infraestrutura de TI com IA  ·  Documento Executivo</a:t>
-            </a:r>
-          </a:p>
-        </p:txBody>
-      </p:sp>
-      <p:sp>
-        <p:nvSpPr>
-          <p:cNvPr id="36" name="TextBox 35"/>
+                  <a:srgbClr val="5E6A72"/>
+                </a:solidFill>
+                <a:latin typeface="Calibri"/>
+              </a:rPr>
+              <a:t>Infraestrutura de TI com IA  ·  Documento Executivo</a:t>
+            </a:r>
+          </a:p>
+        </p:txBody>
+      </p:sp>
+      <p:sp>
+        <p:nvSpPr>
+          <p:cNvPr id="37" name="TextBox 36"/>
           <p:cNvSpPr txBox="1"/>
           <p:nvPr/>
         </p:nvSpPr>
@@ -9402,7 +9576,7 @@
             <a:r>
               <a:rPr sz="900" b="1" i="0">
                 <a:solidFill>
-                  <a:srgbClr val="5B6B7B"/>
+                  <a:srgbClr val="5E6A72"/>
                 </a:solidFill>
                 <a:latin typeface="Calibri"/>
               </a:rPr>
@@ -9444,7 +9618,7 @@
             <a:avLst/>
           </a:prstGeom>
           <a:solidFill>
-            <a:srgbClr val="0F2740"/>
+            <a:srgbClr val="003C54"/>
           </a:solidFill>
           <a:ln>
             <a:noFill/>
@@ -9488,7 +9662,7 @@
             <a:avLst/>
           </a:prstGeom>
           <a:solidFill>
-            <a:srgbClr val="F5A623"/>
+            <a:srgbClr val="4E86AE"/>
           </a:solidFill>
           <a:ln>
             <a:noFill/>
@@ -9553,7 +9727,7 @@
             <a:r>
               <a:rPr sz="1200" b="1" i="0">
                 <a:solidFill>
-                  <a:srgbClr val="0FB5AE"/>
+                  <a:srgbClr val="1F97B4"/>
                 </a:solidFill>
                 <a:latin typeface="Calibri"/>
               </a:rPr>
@@ -9652,7 +9826,7 @@
             <a:r>
               <a:rPr sz="1500" b="1" i="0">
                 <a:solidFill>
-                  <a:srgbClr val="0F2740"/>
+                  <a:srgbClr val="003C54"/>
                 </a:solidFill>
                 <a:latin typeface="Calibri"/>
               </a:rPr>
@@ -9670,7 +9844,7 @@
             <a:r>
               <a:rPr sz="1500" b="1" i="0">
                 <a:solidFill>
-                  <a:srgbClr val="0F2740"/>
+                  <a:srgbClr val="003C54"/>
                 </a:solidFill>
                 <a:latin typeface="Calibri"/>
               </a:rPr>
@@ -9705,7 +9879,7 @@
             </a:avLst>
           </a:prstGeom>
           <a:solidFill>
-            <a:srgbClr val="EAF2FB"/>
+            <a:srgbClr val="E4EEF4"/>
           </a:solidFill>
           <a:ln>
             <a:noFill/>
@@ -9770,7 +9944,7 @@
             <a:r>
               <a:rPr sz="1500" b="1" i="0">
                 <a:solidFill>
-                  <a:srgbClr val="1F6FEB"/>
+                  <a:srgbClr val="0E6E92"/>
                 </a:solidFill>
                 <a:latin typeface="Calibri"/>
               </a:rPr>
@@ -9812,7 +9986,7 @@
             <a:r>
               <a:rPr sz="1350" b="1">
                 <a:solidFill>
-                  <a:srgbClr val="1F6FEB"/>
+                  <a:srgbClr val="0E6E92"/>
                 </a:solidFill>
                 <a:latin typeface="Calibri"/>
               </a:rPr>
@@ -9821,7 +9995,7 @@
             <a:r>
               <a:rPr sz="1350" b="1">
                 <a:solidFill>
-                  <a:srgbClr val="0F2740"/>
+                  <a:srgbClr val="003C54"/>
                 </a:solidFill>
                 <a:latin typeface="Calibri"/>
               </a:rPr>
@@ -9849,7 +10023,7 @@
             <a:r>
               <a:rPr sz="1350" b="1">
                 <a:solidFill>
-                  <a:srgbClr val="1F6FEB"/>
+                  <a:srgbClr val="0E6E92"/>
                 </a:solidFill>
                 <a:latin typeface="Calibri"/>
               </a:rPr>
@@ -9858,7 +10032,7 @@
             <a:r>
               <a:rPr sz="1350" b="1">
                 <a:solidFill>
-                  <a:srgbClr val="0F2740"/>
+                  <a:srgbClr val="003C54"/>
                 </a:solidFill>
                 <a:latin typeface="Calibri"/>
               </a:rPr>
@@ -9886,7 +10060,7 @@
             <a:r>
               <a:rPr sz="1350" b="1">
                 <a:solidFill>
-                  <a:srgbClr val="1F6FEB"/>
+                  <a:srgbClr val="0E6E92"/>
                 </a:solidFill>
                 <a:latin typeface="Calibri"/>
               </a:rPr>
@@ -9895,7 +10069,7 @@
             <a:r>
               <a:rPr sz="1350" b="1">
                 <a:solidFill>
-                  <a:srgbClr val="0F2740"/>
+                  <a:srgbClr val="003C54"/>
                 </a:solidFill>
                 <a:latin typeface="Calibri"/>
               </a:rPr>
@@ -9930,7 +10104,7 @@
             </a:avLst>
           </a:prstGeom>
           <a:solidFill>
-            <a:srgbClr val="E6F7F6"/>
+            <a:srgbClr val="E1F0F4"/>
           </a:solidFill>
           <a:ln>
             <a:noFill/>
@@ -9995,7 +10169,7 @@
             <a:r>
               <a:rPr sz="1500" b="1" i="0">
                 <a:solidFill>
-                  <a:srgbClr val="0FB5AE"/>
+                  <a:srgbClr val="1F97B4"/>
                 </a:solidFill>
                 <a:latin typeface="Calibri"/>
               </a:rPr>
@@ -10062,7 +10236,7 @@
             <a:r>
               <a:rPr sz="1400" b="1" i="0">
                 <a:solidFill>
-                  <a:srgbClr val="0F2740"/>
+                  <a:srgbClr val="003C54"/>
                 </a:solidFill>
                 <a:latin typeface="Calibri"/>
               </a:rPr>
@@ -10071,15 +10245,39 @@
           </a:p>
         </p:txBody>
       </p:sp>
-      <p:sp>
-        <p:nvSpPr>
-          <p:cNvPr id="13" name="TextBox 12"/>
+      <p:pic>
+        <p:nvPicPr>
+          <p:cNvPr id="13" name="Picture 12" descr="setup_logo@hi.png"/>
+          <p:cNvPicPr>
+            <a:picLocks noChangeAspect="1"/>
+          </p:cNvPicPr>
+          <p:nvPr/>
+        </p:nvPicPr>
+        <p:blipFill>
+          <a:blip r:embed="rId2"/>
+          <a:stretch>
+            <a:fillRect/>
+          </a:stretch>
+        </p:blipFill>
+        <p:spPr>
+          <a:xfrm>
+            <a:off x="502920" y="6419088"/>
+            <a:ext cx="646611" cy="201168"/>
+          </a:xfrm>
+          <a:prstGeom prst="rect">
+            <a:avLst/>
+          </a:prstGeom>
+        </p:spPr>
+      </p:pic>
+      <p:sp>
+        <p:nvSpPr>
+          <p:cNvPr id="14" name="TextBox 13"/>
           <p:cNvSpPr txBox="1"/>
           <p:nvPr/>
         </p:nvSpPr>
         <p:spPr>
           <a:xfrm>
-            <a:off x="502920" y="6455664"/>
+            <a:off x="1554480" y="6455664"/>
             <a:ext cx="8229600" cy="274320"/>
           </a:xfrm>
           <a:prstGeom prst="rect">
@@ -10107,18 +10305,18 @@
             <a:r>
               <a:rPr sz="900" b="0" i="0">
                 <a:solidFill>
-                  <a:srgbClr val="5B6B7B"/>
-                </a:solidFill>
-                <a:latin typeface="Calibri"/>
-              </a:rPr>
-              <a:t>setup.com.br  ·  Infraestrutura de TI com IA  ·  Documento Executivo</a:t>
-            </a:r>
-          </a:p>
-        </p:txBody>
-      </p:sp>
-      <p:sp>
-        <p:nvSpPr>
-          <p:cNvPr id="14" name="TextBox 13"/>
+                  <a:srgbClr val="5E6A72"/>
+                </a:solidFill>
+                <a:latin typeface="Calibri"/>
+              </a:rPr>
+              <a:t>Infraestrutura de TI com IA  ·  Documento Executivo</a:t>
+            </a:r>
+          </a:p>
+        </p:txBody>
+      </p:sp>
+      <p:sp>
+        <p:nvSpPr>
+          <p:cNvPr id="15" name="TextBox 14"/>
           <p:cNvSpPr txBox="1"/>
           <p:nvPr/>
         </p:nvSpPr>
@@ -10152,7 +10350,7 @@
             <a:r>
               <a:rPr sz="900" b="1" i="0">
                 <a:solidFill>
-                  <a:srgbClr val="5B6B7B"/>
+                  <a:srgbClr val="5E6A72"/>
                 </a:solidFill>
                 <a:latin typeface="Calibri"/>
               </a:rPr>
@@ -10194,7 +10392,7 @@
             <a:avLst/>
           </a:prstGeom>
           <a:solidFill>
-            <a:srgbClr val="2E8B57"/>
+            <a:srgbClr val="003C54"/>
           </a:solidFill>
           <a:ln>
             <a:noFill/>
@@ -10259,7 +10457,7 @@
             <a:r>
               <a:rPr sz="1300" b="1" i="0">
                 <a:solidFill>
-                  <a:srgbClr val="0F2740"/>
+                  <a:srgbClr val="003C54"/>
                 </a:solidFill>
                 <a:latin typeface="Calibri"/>
               </a:rPr>
@@ -10328,7 +10526,7 @@
             <a:r>
               <a:rPr sz="1400" b="1" i="0">
                 <a:solidFill>
-                  <a:srgbClr val="0F2740"/>
+                  <a:srgbClr val="003C54"/>
                 </a:solidFill>
                 <a:latin typeface="Calibri"/>
               </a:rPr>
@@ -10346,15 +10544,39 @@
           </a:p>
         </p:txBody>
       </p:sp>
-      <p:sp>
-        <p:nvSpPr>
-          <p:cNvPr id="6" name="TextBox 5"/>
+      <p:pic>
+        <p:nvPicPr>
+          <p:cNvPr id="6" name="Picture 5" descr="setup_logo@hi.png"/>
+          <p:cNvPicPr>
+            <a:picLocks noChangeAspect="1"/>
+          </p:cNvPicPr>
+          <p:nvPr/>
+        </p:nvPicPr>
+        <p:blipFill>
+          <a:blip r:embed="rId3"/>
+          <a:stretch>
+            <a:fillRect/>
+          </a:stretch>
+        </p:blipFill>
+        <p:spPr>
+          <a:xfrm>
+            <a:off x="502920" y="6419088"/>
+            <a:ext cx="646611" cy="201168"/>
+          </a:xfrm>
+          <a:prstGeom prst="rect">
+            <a:avLst/>
+          </a:prstGeom>
+        </p:spPr>
+      </p:pic>
+      <p:sp>
+        <p:nvSpPr>
+          <p:cNvPr id="7" name="TextBox 6"/>
           <p:cNvSpPr txBox="1"/>
           <p:nvPr/>
         </p:nvSpPr>
         <p:spPr>
           <a:xfrm>
-            <a:off x="502920" y="6455664"/>
+            <a:off x="1554480" y="6455664"/>
             <a:ext cx="8229600" cy="274320"/>
           </a:xfrm>
           <a:prstGeom prst="rect">
@@ -10382,18 +10604,18 @@
             <a:r>
               <a:rPr sz="900" b="0" i="0">
                 <a:solidFill>
-                  <a:srgbClr val="5B6B7B"/>
-                </a:solidFill>
-                <a:latin typeface="Calibri"/>
-              </a:rPr>
-              <a:t>setup.com.br  ·  Infraestrutura de TI com IA  ·  Documento Executivo</a:t>
-            </a:r>
-          </a:p>
-        </p:txBody>
-      </p:sp>
-      <p:sp>
-        <p:nvSpPr>
-          <p:cNvPr id="7" name="TextBox 6"/>
+                  <a:srgbClr val="5E6A72"/>
+                </a:solidFill>
+                <a:latin typeface="Calibri"/>
+              </a:rPr>
+              <a:t>Infraestrutura de TI com IA  ·  Documento Executivo</a:t>
+            </a:r>
+          </a:p>
+        </p:txBody>
+      </p:sp>
+      <p:sp>
+        <p:nvSpPr>
+          <p:cNvPr id="8" name="TextBox 7"/>
           <p:cNvSpPr txBox="1"/>
           <p:nvPr/>
         </p:nvSpPr>
@@ -10427,7 +10649,7 @@
             <a:r>
               <a:rPr sz="900" b="1" i="0">
                 <a:solidFill>
-                  <a:srgbClr val="5B6B7B"/>
+                  <a:srgbClr val="5E6A72"/>
                 </a:solidFill>
                 <a:latin typeface="Calibri"/>
               </a:rPr>

</xml_diff>

<commit_message>
docs: ajusta rodape do deck e gera PDF completo dos slides
- Espacamento do rodape do .pptx (logo + texto sem sobreposicao).
- render_pptx.py com resolucao configuravel e altura de linha proporcional.
- Gera PDF com os 13 slides (full color, FlateDecode, sem dependencia de
  Office/poppler) como arquivo completo portatil.
</commit_message>
<xml_diff>
--- a/docs/Infraestrutura-IA-setup.com.br.pptx
+++ b/docs/Infraestrutura-IA-setup.com.br.pptx
@@ -3937,8 +3937,8 @@
         </p:blipFill>
         <p:spPr>
           <a:xfrm>
-            <a:off x="502920" y="6419088"/>
-            <a:ext cx="646611" cy="201168"/>
+            <a:off x="502920" y="6437376"/>
+            <a:ext cx="587829" cy="182880"/>
           </a:xfrm>
           <a:prstGeom prst="rect">
             <a:avLst/>
@@ -3953,8 +3953,8 @@
         </p:nvSpPr>
         <p:spPr>
           <a:xfrm>
-            <a:off x="1554480" y="6455664"/>
-            <a:ext cx="8229600" cy="274320"/>
+            <a:off x="1417320" y="6455664"/>
+            <a:ext cx="8686800" cy="274320"/>
           </a:xfrm>
           <a:prstGeom prst="rect">
             <a:avLst/>
@@ -3985,7 +3985,7 @@
                 </a:solidFill>
                 <a:latin typeface="Calibri"/>
               </a:rPr>
-              <a:t>Infraestrutura de TI com IA  ·  Documento Executivo</a:t>
+              <a:t>·  Infraestrutura de TI com IA  ·  Documento Executivo</a:t>
             </a:r>
           </a:p>
         </p:txBody>
@@ -4182,8 +4182,8 @@
         </p:blipFill>
         <p:spPr>
           <a:xfrm>
-            <a:off x="502920" y="6419088"/>
-            <a:ext cx="646611" cy="201168"/>
+            <a:off x="502920" y="6437376"/>
+            <a:ext cx="587829" cy="182880"/>
           </a:xfrm>
           <a:prstGeom prst="rect">
             <a:avLst/>
@@ -4198,8 +4198,8 @@
         </p:nvSpPr>
         <p:spPr>
           <a:xfrm>
-            <a:off x="1554480" y="6455664"/>
-            <a:ext cx="8229600" cy="274320"/>
+            <a:off x="1417320" y="6455664"/>
+            <a:ext cx="8686800" cy="274320"/>
           </a:xfrm>
           <a:prstGeom prst="rect">
             <a:avLst/>
@@ -4230,7 +4230,7 @@
                 </a:solidFill>
                 <a:latin typeface="Calibri"/>
               </a:rPr>
-              <a:t>Infraestrutura de TI com IA  ·  Documento Executivo</a:t>
+              <a:t>·  Infraestrutura de TI com IA  ·  Documento Executivo</a:t>
             </a:r>
           </a:p>
         </p:txBody>
@@ -4472,8 +4472,8 @@
         </p:blipFill>
         <p:spPr>
           <a:xfrm>
-            <a:off x="502920" y="6419088"/>
-            <a:ext cx="646611" cy="201168"/>
+            <a:off x="502920" y="6437376"/>
+            <a:ext cx="587829" cy="182880"/>
           </a:xfrm>
           <a:prstGeom prst="rect">
             <a:avLst/>
@@ -4488,8 +4488,8 @@
         </p:nvSpPr>
         <p:spPr>
           <a:xfrm>
-            <a:off x="1554480" y="6455664"/>
-            <a:ext cx="8229600" cy="274320"/>
+            <a:off x="1417320" y="6455664"/>
+            <a:ext cx="8686800" cy="274320"/>
           </a:xfrm>
           <a:prstGeom prst="rect">
             <a:avLst/>
@@ -4520,7 +4520,7 @@
                 </a:solidFill>
                 <a:latin typeface="Calibri"/>
               </a:rPr>
-              <a:t>Infraestrutura de TI com IA  ·  Documento Executivo</a:t>
+              <a:t>·  Infraestrutura de TI com IA  ·  Documento Executivo</a:t>
             </a:r>
           </a:p>
         </p:txBody>
@@ -5778,8 +5778,8 @@
         </p:blipFill>
         <p:spPr>
           <a:xfrm>
-            <a:off x="502920" y="6419088"/>
-            <a:ext cx="646611" cy="201168"/>
+            <a:off x="502920" y="6437376"/>
+            <a:ext cx="587829" cy="182880"/>
           </a:xfrm>
           <a:prstGeom prst="rect">
             <a:avLst/>
@@ -5794,8 +5794,8 @@
         </p:nvSpPr>
         <p:spPr>
           <a:xfrm>
-            <a:off x="1554480" y="6455664"/>
-            <a:ext cx="8229600" cy="274320"/>
+            <a:off x="1417320" y="6455664"/>
+            <a:ext cx="8686800" cy="274320"/>
           </a:xfrm>
           <a:prstGeom prst="rect">
             <a:avLst/>
@@ -5826,7 +5826,7 @@
                 </a:solidFill>
                 <a:latin typeface="Calibri"/>
               </a:rPr>
-              <a:t>Infraestrutura de TI com IA  ·  Documento Executivo</a:t>
+              <a:t>·  Infraestrutura de TI com IA  ·  Documento Executivo</a:t>
             </a:r>
           </a:p>
         </p:txBody>
@@ -6023,8 +6023,8 @@
         </p:blipFill>
         <p:spPr>
           <a:xfrm>
-            <a:off x="502920" y="6419088"/>
-            <a:ext cx="646611" cy="201168"/>
+            <a:off x="502920" y="6437376"/>
+            <a:ext cx="587829" cy="182880"/>
           </a:xfrm>
           <a:prstGeom prst="rect">
             <a:avLst/>
@@ -6039,8 +6039,8 @@
         </p:nvSpPr>
         <p:spPr>
           <a:xfrm>
-            <a:off x="1554480" y="6455664"/>
-            <a:ext cx="8229600" cy="274320"/>
+            <a:off x="1417320" y="6455664"/>
+            <a:ext cx="8686800" cy="274320"/>
           </a:xfrm>
           <a:prstGeom prst="rect">
             <a:avLst/>
@@ -6071,7 +6071,7 @@
                 </a:solidFill>
                 <a:latin typeface="Calibri"/>
               </a:rPr>
-              <a:t>Infraestrutura de TI com IA  ·  Documento Executivo</a:t>
+              <a:t>·  Infraestrutura de TI com IA  ·  Documento Executivo</a:t>
             </a:r>
           </a:p>
         </p:txBody>
@@ -7058,8 +7058,8 @@
         </p:blipFill>
         <p:spPr>
           <a:xfrm>
-            <a:off x="502920" y="6419088"/>
-            <a:ext cx="646611" cy="201168"/>
+            <a:off x="502920" y="6437376"/>
+            <a:ext cx="587829" cy="182880"/>
           </a:xfrm>
           <a:prstGeom prst="rect">
             <a:avLst/>
@@ -7074,8 +7074,8 @@
         </p:nvSpPr>
         <p:spPr>
           <a:xfrm>
-            <a:off x="1554480" y="6455664"/>
-            <a:ext cx="8229600" cy="274320"/>
+            <a:off x="1417320" y="6455664"/>
+            <a:ext cx="8686800" cy="274320"/>
           </a:xfrm>
           <a:prstGeom prst="rect">
             <a:avLst/>
@@ -7106,7 +7106,7 @@
                 </a:solidFill>
                 <a:latin typeface="Calibri"/>
               </a:rPr>
-              <a:t>Infraestrutura de TI com IA  ·  Documento Executivo</a:t>
+              <a:t>·  Infraestrutura de TI com IA  ·  Documento Executivo</a:t>
             </a:r>
           </a:p>
         </p:txBody>
@@ -7348,8 +7348,8 @@
         </p:blipFill>
         <p:spPr>
           <a:xfrm>
-            <a:off x="502920" y="6419088"/>
-            <a:ext cx="646611" cy="201168"/>
+            <a:off x="502920" y="6437376"/>
+            <a:ext cx="587829" cy="182880"/>
           </a:xfrm>
           <a:prstGeom prst="rect">
             <a:avLst/>
@@ -7364,8 +7364,8 @@
         </p:nvSpPr>
         <p:spPr>
           <a:xfrm>
-            <a:off x="1554480" y="6455664"/>
-            <a:ext cx="8229600" cy="274320"/>
+            <a:off x="1417320" y="6455664"/>
+            <a:ext cx="8686800" cy="274320"/>
           </a:xfrm>
           <a:prstGeom prst="rect">
             <a:avLst/>
@@ -7396,7 +7396,7 @@
                 </a:solidFill>
                 <a:latin typeface="Calibri"/>
               </a:rPr>
-              <a:t>Infraestrutura de TI com IA  ·  Documento Executivo</a:t>
+              <a:t>·  Infraestrutura de TI com IA  ·  Documento Executivo</a:t>
             </a:r>
           </a:p>
         </p:txBody>
@@ -7872,8 +7872,8 @@
         </p:blipFill>
         <p:spPr>
           <a:xfrm>
-            <a:off x="502920" y="6419088"/>
-            <a:ext cx="646611" cy="201168"/>
+            <a:off x="502920" y="6437376"/>
+            <a:ext cx="587829" cy="182880"/>
           </a:xfrm>
           <a:prstGeom prst="rect">
             <a:avLst/>
@@ -7888,8 +7888,8 @@
         </p:nvSpPr>
         <p:spPr>
           <a:xfrm>
-            <a:off x="1554480" y="6455664"/>
-            <a:ext cx="8229600" cy="274320"/>
+            <a:off x="1417320" y="6455664"/>
+            <a:ext cx="8686800" cy="274320"/>
           </a:xfrm>
           <a:prstGeom prst="rect">
             <a:avLst/>
@@ -7920,7 +7920,7 @@
                 </a:solidFill>
                 <a:latin typeface="Calibri"/>
               </a:rPr>
-              <a:t>Infraestrutura de TI com IA  ·  Documento Executivo</a:t>
+              <a:t>·  Infraestrutura de TI com IA  ·  Documento Executivo</a:t>
             </a:r>
           </a:p>
         </p:txBody>
@@ -9487,8 +9487,8 @@
         </p:blipFill>
         <p:spPr>
           <a:xfrm>
-            <a:off x="502920" y="6419088"/>
-            <a:ext cx="646611" cy="201168"/>
+            <a:off x="502920" y="6437376"/>
+            <a:ext cx="587829" cy="182880"/>
           </a:xfrm>
           <a:prstGeom prst="rect">
             <a:avLst/>
@@ -9503,8 +9503,8 @@
         </p:nvSpPr>
         <p:spPr>
           <a:xfrm>
-            <a:off x="1554480" y="6455664"/>
-            <a:ext cx="8229600" cy="274320"/>
+            <a:off x="1417320" y="6455664"/>
+            <a:ext cx="8686800" cy="274320"/>
           </a:xfrm>
           <a:prstGeom prst="rect">
             <a:avLst/>
@@ -9535,7 +9535,7 @@
                 </a:solidFill>
                 <a:latin typeface="Calibri"/>
               </a:rPr>
-              <a:t>Infraestrutura de TI com IA  ·  Documento Executivo</a:t>
+              <a:t>·  Infraestrutura de TI com IA  ·  Documento Executivo</a:t>
             </a:r>
           </a:p>
         </p:txBody>
@@ -10261,8 +10261,8 @@
         </p:blipFill>
         <p:spPr>
           <a:xfrm>
-            <a:off x="502920" y="6419088"/>
-            <a:ext cx="646611" cy="201168"/>
+            <a:off x="502920" y="6437376"/>
+            <a:ext cx="587829" cy="182880"/>
           </a:xfrm>
           <a:prstGeom prst="rect">
             <a:avLst/>
@@ -10277,8 +10277,8 @@
         </p:nvSpPr>
         <p:spPr>
           <a:xfrm>
-            <a:off x="1554480" y="6455664"/>
-            <a:ext cx="8229600" cy="274320"/>
+            <a:off x="1417320" y="6455664"/>
+            <a:ext cx="8686800" cy="274320"/>
           </a:xfrm>
           <a:prstGeom prst="rect">
             <a:avLst/>
@@ -10309,7 +10309,7 @@
                 </a:solidFill>
                 <a:latin typeface="Calibri"/>
               </a:rPr>
-              <a:t>Infraestrutura de TI com IA  ·  Documento Executivo</a:t>
+              <a:t>·  Infraestrutura de TI com IA  ·  Documento Executivo</a:t>
             </a:r>
           </a:p>
         </p:txBody>
@@ -10560,8 +10560,8 @@
         </p:blipFill>
         <p:spPr>
           <a:xfrm>
-            <a:off x="502920" y="6419088"/>
-            <a:ext cx="646611" cy="201168"/>
+            <a:off x="502920" y="6437376"/>
+            <a:ext cx="587829" cy="182880"/>
           </a:xfrm>
           <a:prstGeom prst="rect">
             <a:avLst/>
@@ -10576,8 +10576,8 @@
         </p:nvSpPr>
         <p:spPr>
           <a:xfrm>
-            <a:off x="1554480" y="6455664"/>
-            <a:ext cx="8229600" cy="274320"/>
+            <a:off x="1417320" y="6455664"/>
+            <a:ext cx="8686800" cy="274320"/>
           </a:xfrm>
           <a:prstGeom prst="rect">
             <a:avLst/>
@@ -10608,7 +10608,7 @@
                 </a:solidFill>
                 <a:latin typeface="Calibri"/>
               </a:rPr>
-              <a:t>Infraestrutura de TI com IA  ·  Documento Executivo</a:t>
+              <a:t>·  Infraestrutura de TI com IA  ·  Documento Executivo</a:t>
             </a:r>
           </a:p>
         </p:txBody>

</xml_diff>